<commit_message>
Rebuild UI as multi-view dashboard, add live parameter bar, outcome probabilities, index ticker, and Claude assistant
</commit_message>
<xml_diff>
--- a/docs/AI-Investment-Advisor.pptx
+++ b/docs/AI-Investment-Advisor.pptx
@@ -6464,7 +6464,7 @@
                 </a:solidFill>
                 <a:latin typeface="Calibri"/>
               </a:rPr>
-              <a:t>Both models are small and easy to explain. Neither one predicts prices, and neither is a guarantee.</a:t>
+              <a:t>Both models are small enough to explain on one slide, and both run live on every request.</a:t>
             </a:r>
           </a:p>
         </p:txBody>
@@ -6765,7 +6765,7 @@
                 </a:solidFill>
                 <a:latin typeface="Calibri"/>
               </a:rPr>
-              <a:t>The app is live now. Built with React and FastAPI, code on GitHub.</a:t>
+              <a:t>Live now. React and FastAPI, with a built-in assistant on Claude Sonnet. Code on GitHub.</a:t>
             </a:r>
           </a:p>
         </p:txBody>

</xml_diff>